<commit_message>
Navy slides show a single attribution line - skip the standard footer chrome there
</commit_message>
<xml_diff>
--- a/public/downloads/US-252034-Monitor-Evaluate-Performance.pptx
+++ b/public/downloads/US-252034-Monitor-Evaluate-Performance.pptx
@@ -13222,92 +13222,14 @@
       </p:grpSpPr>
       <p:sp>
         <p:nvSpPr>
-          <p:cNvPr id="2" name="Text 0"/>
-          <p:cNvSpPr/>
-          <p:nvPr/>
-        </p:nvSpPr>
-        <p:spPr>
-          <a:xfrm>
-            <a:off x="502920" y="6437376"/>
-            <a:ext cx="10268712" cy="310896"/>
-          </a:xfrm>
-          <a:prstGeom prst="rect">
-            <a:avLst/>
-          </a:prstGeom>
-          <a:noFill/>
-          <a:ln/>
-        </p:spPr>
-        <p:txBody>
-          <a:bodyPr wrap="square" rtlCol="0" anchor="ctr"/>
-          <a:lstStyle/>
-          <a:p>
-            <a:pPr indent="0" marL="0">
-              <a:buNone/>
-            </a:pPr>
-            <a:r>
-              <a:rPr lang="en-US" sz="1200" dirty="0">
-                <a:solidFill>
-                  <a:srgbClr val="6B7280"/>
-                </a:solidFill>
-                <a:latin typeface="Aptos" pitchFamily="34" charset="0"/>
-                <a:ea typeface="Aptos" pitchFamily="34" charset="-122"/>
-                <a:cs typeface="Aptos" pitchFamily="34" charset="-120"/>
-              </a:rPr>
-              <a:t>US 252034 · Monitor and evaluate team members against performance standards · NQF 5 · 8 credits</a:t>
-            </a:r>
-            <a:endParaRPr lang="en-US" sz="1200" dirty="0"/>
-          </a:p>
-        </p:txBody>
-      </p:sp>
-      <p:sp>
-        <p:nvSpPr>
-          <p:cNvPr id="3" name="Text 1"/>
-          <p:cNvSpPr/>
-          <p:nvPr/>
-        </p:nvSpPr>
-        <p:spPr>
-          <a:xfrm>
-            <a:off x="11045952" y="6437376"/>
-            <a:ext cx="640080" cy="310896"/>
-          </a:xfrm>
-          <a:prstGeom prst="rect">
-            <a:avLst/>
-          </a:prstGeom>
-          <a:noFill/>
-          <a:ln/>
-        </p:spPr>
-        <p:txBody>
-          <a:bodyPr wrap="square" rtlCol="0" anchor="ctr"/>
-          <a:lstStyle/>
-          <a:p>
-            <a:pPr algn="r" indent="0" marL="0">
-              <a:buNone/>
-            </a:pPr>
-            <a:r>
-              <a:rPr lang="en-US" sz="1200" dirty="0">
-                <a:solidFill>
-                  <a:srgbClr val="6B7280"/>
-                </a:solidFill>
-                <a:latin typeface="Aptos" pitchFamily="34" charset="0"/>
-                <a:ea typeface="Aptos" pitchFamily="34" charset="-122"/>
-                <a:cs typeface="Aptos" pitchFamily="34" charset="-120"/>
-              </a:rPr>
-              <a:t>2</a:t>
-            </a:r>
-            <a:endParaRPr lang="en-US" sz="1200" dirty="0"/>
-          </a:p>
-        </p:txBody>
-      </p:sp>
-      <p:sp>
-        <p:nvSpPr>
-          <p:cNvPr id="4" name="Shape 2"/>
+          <p:cNvPr id="2" name="Shape 0"/>
           <p:cNvSpPr/>
           <p:nvPr/>
         </p:nvSpPr>
         <p:spPr>
           <a:xfrm>
             <a:off x="0" y="0"/>
-            <a:ext cx="12188952" cy="82296"/>
+            <a:ext cx="12188952" cy="109728"/>
           </a:xfrm>
           <a:prstGeom prst="rect">
             <a:avLst/>
@@ -13320,27 +13242,7 @@
       </p:sp>
       <p:sp>
         <p:nvSpPr>
-          <p:cNvPr id="5" name="Shape 3"/>
-          <p:cNvSpPr/>
-          <p:nvPr/>
-        </p:nvSpPr>
-        <p:spPr>
-          <a:xfrm>
-            <a:off x="0" y="0"/>
-            <a:ext cx="12188952" cy="109728"/>
-          </a:xfrm>
-          <a:prstGeom prst="rect">
-            <a:avLst/>
-          </a:prstGeom>
-          <a:solidFill>
-            <a:srgbClr val="0F6CBD"/>
-          </a:solidFill>
-          <a:ln/>
-        </p:spPr>
-      </p:sp>
-      <p:sp>
-        <p:nvSpPr>
-          <p:cNvPr id="6" name="Text 4"/>
+          <p:cNvPr id="3" name="Text 1"/>
           <p:cNvSpPr/>
           <p:nvPr/>
         </p:nvSpPr>
@@ -13379,7 +13281,7 @@
       </p:sp>
       <p:sp>
         <p:nvSpPr>
-          <p:cNvPr id="7" name="Text 5"/>
+          <p:cNvPr id="4" name="Text 2"/>
           <p:cNvSpPr/>
           <p:nvPr/>
         </p:nvSpPr>
@@ -13418,7 +13320,7 @@
       </p:sp>
       <p:pic>
         <p:nvPicPr>
-          <p:cNvPr id="8" name="Image 0" descr="preencoded.png">    </p:cNvPr>
+          <p:cNvPr id="5" name="Image 0" descr="preencoded.png">    </p:cNvPr>
           <p:cNvPicPr>
             <a:picLocks noChangeAspect="1"/>
           </p:cNvPicPr>
@@ -13448,7 +13350,7 @@
       </p:pic>
       <p:sp>
         <p:nvSpPr>
-          <p:cNvPr id="9" name="Text 6"/>
+          <p:cNvPr id="6" name="Text 3"/>
           <p:cNvSpPr/>
           <p:nvPr/>
         </p:nvSpPr>
@@ -25810,92 +25712,14 @@
       </p:grpSpPr>
       <p:sp>
         <p:nvSpPr>
-          <p:cNvPr id="2" name="Text 0"/>
-          <p:cNvSpPr/>
-          <p:nvPr/>
-        </p:nvSpPr>
-        <p:spPr>
-          <a:xfrm>
-            <a:off x="502920" y="6437376"/>
-            <a:ext cx="10268712" cy="310896"/>
-          </a:xfrm>
-          <a:prstGeom prst="rect">
-            <a:avLst/>
-          </a:prstGeom>
-          <a:noFill/>
-          <a:ln/>
-        </p:spPr>
-        <p:txBody>
-          <a:bodyPr wrap="square" rtlCol="0" anchor="ctr"/>
-          <a:lstStyle/>
-          <a:p>
-            <a:pPr indent="0" marL="0">
-              <a:buNone/>
-            </a:pPr>
-            <a:r>
-              <a:rPr lang="en-US" sz="1200" dirty="0">
-                <a:solidFill>
-                  <a:srgbClr val="6B7280"/>
-                </a:solidFill>
-                <a:latin typeface="Aptos" pitchFamily="34" charset="0"/>
-                <a:ea typeface="Aptos" pitchFamily="34" charset="-122"/>
-                <a:cs typeface="Aptos" pitchFamily="34" charset="-120"/>
-              </a:rPr>
-              <a:t>US 252034 · Monitor and evaluate team members against performance standards · NQF 5 · 8 credits</a:t>
-            </a:r>
-            <a:endParaRPr lang="en-US" sz="1200" dirty="0"/>
-          </a:p>
-        </p:txBody>
-      </p:sp>
-      <p:sp>
-        <p:nvSpPr>
-          <p:cNvPr id="3" name="Text 1"/>
-          <p:cNvSpPr/>
-          <p:nvPr/>
-        </p:nvSpPr>
-        <p:spPr>
-          <a:xfrm>
-            <a:off x="11045952" y="6437376"/>
-            <a:ext cx="640080" cy="310896"/>
-          </a:xfrm>
-          <a:prstGeom prst="rect">
-            <a:avLst/>
-          </a:prstGeom>
-          <a:noFill/>
-          <a:ln/>
-        </p:spPr>
-        <p:txBody>
-          <a:bodyPr wrap="square" rtlCol="0" anchor="ctr"/>
-          <a:lstStyle/>
-          <a:p>
-            <a:pPr algn="r" indent="0" marL="0">
-              <a:buNone/>
-            </a:pPr>
-            <a:r>
-              <a:rPr lang="en-US" sz="1200" dirty="0">
-                <a:solidFill>
-                  <a:srgbClr val="6B7280"/>
-                </a:solidFill>
-                <a:latin typeface="Aptos" pitchFamily="34" charset="0"/>
-                <a:ea typeface="Aptos" pitchFamily="34" charset="-122"/>
-                <a:cs typeface="Aptos" pitchFamily="34" charset="-120"/>
-              </a:rPr>
-              <a:t>36</a:t>
-            </a:r>
-            <a:endParaRPr lang="en-US" sz="1200" dirty="0"/>
-          </a:p>
-        </p:txBody>
-      </p:sp>
-      <p:sp>
-        <p:nvSpPr>
-          <p:cNvPr id="4" name="Shape 2"/>
+          <p:cNvPr id="2" name="Shape 0"/>
           <p:cNvSpPr/>
           <p:nvPr/>
         </p:nvSpPr>
         <p:spPr>
           <a:xfrm>
             <a:off x="0" y="0"/>
-            <a:ext cx="12188952" cy="82296"/>
+            <a:ext cx="12188952" cy="109728"/>
           </a:xfrm>
           <a:prstGeom prst="rect">
             <a:avLst/>
@@ -25908,27 +25732,7 @@
       </p:sp>
       <p:sp>
         <p:nvSpPr>
-          <p:cNvPr id="5" name="Shape 3"/>
-          <p:cNvSpPr/>
-          <p:nvPr/>
-        </p:nvSpPr>
-        <p:spPr>
-          <a:xfrm>
-            <a:off x="0" y="0"/>
-            <a:ext cx="12188952" cy="109728"/>
-          </a:xfrm>
-          <a:prstGeom prst="rect">
-            <a:avLst/>
-          </a:prstGeom>
-          <a:solidFill>
-            <a:srgbClr val="0F6CBD"/>
-          </a:solidFill>
-          <a:ln/>
-        </p:spPr>
-      </p:sp>
-      <p:sp>
-        <p:nvSpPr>
-          <p:cNvPr id="6" name="Text 4"/>
+          <p:cNvPr id="3" name="Text 1"/>
           <p:cNvSpPr/>
           <p:nvPr/>
         </p:nvSpPr>
@@ -25967,7 +25771,7 @@
       </p:sp>
       <p:sp>
         <p:nvSpPr>
-          <p:cNvPr id="7" name="Text 5"/>
+          <p:cNvPr id="4" name="Text 2"/>
           <p:cNvSpPr/>
           <p:nvPr/>
         </p:nvSpPr>
@@ -26006,7 +25810,7 @@
       </p:sp>
       <p:pic>
         <p:nvPicPr>
-          <p:cNvPr id="8" name="Image 0" descr="preencoded.png">    </p:cNvPr>
+          <p:cNvPr id="5" name="Image 0" descr="preencoded.png">    </p:cNvPr>
           <p:cNvPicPr>
             <a:picLocks noChangeAspect="1"/>
           </p:cNvPicPr>
@@ -26036,7 +25840,7 @@
       </p:pic>
       <p:sp>
         <p:nvSpPr>
-          <p:cNvPr id="9" name="Text 6"/>
+          <p:cNvPr id="6" name="Text 3"/>
           <p:cNvSpPr/>
           <p:nvPr/>
         </p:nvSpPr>
@@ -31118,92 +30922,14 @@
       </p:grpSpPr>
       <p:sp>
         <p:nvSpPr>
-          <p:cNvPr id="2" name="Text 0"/>
-          <p:cNvSpPr/>
-          <p:nvPr/>
-        </p:nvSpPr>
-        <p:spPr>
-          <a:xfrm>
-            <a:off x="502920" y="6437376"/>
-            <a:ext cx="10268712" cy="310896"/>
-          </a:xfrm>
-          <a:prstGeom prst="rect">
-            <a:avLst/>
-          </a:prstGeom>
-          <a:noFill/>
-          <a:ln/>
-        </p:spPr>
-        <p:txBody>
-          <a:bodyPr wrap="square" rtlCol="0" anchor="ctr"/>
-          <a:lstStyle/>
-          <a:p>
-            <a:pPr indent="0" marL="0">
-              <a:buNone/>
-            </a:pPr>
-            <a:r>
-              <a:rPr lang="en-US" sz="1200" dirty="0">
-                <a:solidFill>
-                  <a:srgbClr val="6B7280"/>
-                </a:solidFill>
-                <a:latin typeface="Aptos" pitchFamily="34" charset="0"/>
-                <a:ea typeface="Aptos" pitchFamily="34" charset="-122"/>
-                <a:cs typeface="Aptos" pitchFamily="34" charset="-120"/>
-              </a:rPr>
-              <a:t>US 252034 · Monitor and evaluate team members against performance standards · NQF 5 · 8 credits</a:t>
-            </a:r>
-            <a:endParaRPr lang="en-US" sz="1200" dirty="0"/>
-          </a:p>
-        </p:txBody>
-      </p:sp>
-      <p:sp>
-        <p:nvSpPr>
-          <p:cNvPr id="3" name="Text 1"/>
-          <p:cNvSpPr/>
-          <p:nvPr/>
-        </p:nvSpPr>
-        <p:spPr>
-          <a:xfrm>
-            <a:off x="11045952" y="6437376"/>
-            <a:ext cx="640080" cy="310896"/>
-          </a:xfrm>
-          <a:prstGeom prst="rect">
-            <a:avLst/>
-          </a:prstGeom>
-          <a:noFill/>
-          <a:ln/>
-        </p:spPr>
-        <p:txBody>
-          <a:bodyPr wrap="square" rtlCol="0" anchor="ctr"/>
-          <a:lstStyle/>
-          <a:p>
-            <a:pPr algn="r" indent="0" marL="0">
-              <a:buNone/>
-            </a:pPr>
-            <a:r>
-              <a:rPr lang="en-US" sz="1200" dirty="0">
-                <a:solidFill>
-                  <a:srgbClr val="6B7280"/>
-                </a:solidFill>
-                <a:latin typeface="Aptos" pitchFamily="34" charset="0"/>
-                <a:ea typeface="Aptos" pitchFamily="34" charset="-122"/>
-                <a:cs typeface="Aptos" pitchFamily="34" charset="-120"/>
-              </a:rPr>
-              <a:t>45</a:t>
-            </a:r>
-            <a:endParaRPr lang="en-US" sz="1200" dirty="0"/>
-          </a:p>
-        </p:txBody>
-      </p:sp>
-      <p:sp>
-        <p:nvSpPr>
-          <p:cNvPr id="4" name="Shape 2"/>
+          <p:cNvPr id="2" name="Shape 0"/>
           <p:cNvSpPr/>
           <p:nvPr/>
         </p:nvSpPr>
         <p:spPr>
           <a:xfrm>
             <a:off x="0" y="0"/>
-            <a:ext cx="12188952" cy="82296"/>
+            <a:ext cx="12188952" cy="109728"/>
           </a:xfrm>
           <a:prstGeom prst="rect">
             <a:avLst/>
@@ -31216,27 +30942,7 @@
       </p:sp>
       <p:sp>
         <p:nvSpPr>
-          <p:cNvPr id="5" name="Shape 3"/>
-          <p:cNvSpPr/>
-          <p:nvPr/>
-        </p:nvSpPr>
-        <p:spPr>
-          <a:xfrm>
-            <a:off x="0" y="0"/>
-            <a:ext cx="12188952" cy="109728"/>
-          </a:xfrm>
-          <a:prstGeom prst="rect">
-            <a:avLst/>
-          </a:prstGeom>
-          <a:solidFill>
-            <a:srgbClr val="0F6CBD"/>
-          </a:solidFill>
-          <a:ln/>
-        </p:spPr>
-      </p:sp>
-      <p:sp>
-        <p:nvSpPr>
-          <p:cNvPr id="6" name="Text 4"/>
+          <p:cNvPr id="3" name="Text 1"/>
           <p:cNvSpPr/>
           <p:nvPr/>
         </p:nvSpPr>
@@ -31275,7 +30981,7 @@
       </p:sp>
       <p:sp>
         <p:nvSpPr>
-          <p:cNvPr id="7" name="Text 5"/>
+          <p:cNvPr id="4" name="Text 2"/>
           <p:cNvSpPr/>
           <p:nvPr/>
         </p:nvSpPr>
@@ -31314,7 +31020,7 @@
       </p:sp>
       <p:pic>
         <p:nvPicPr>
-          <p:cNvPr id="8" name="Image 0" descr="preencoded.png">    </p:cNvPr>
+          <p:cNvPr id="5" name="Image 0" descr="preencoded.png">    </p:cNvPr>
           <p:cNvPicPr>
             <a:picLocks noChangeAspect="1"/>
           </p:cNvPicPr>
@@ -31344,7 +31050,7 @@
       </p:pic>
       <p:sp>
         <p:nvSpPr>
-          <p:cNvPr id="9" name="Text 6"/>
+          <p:cNvPr id="6" name="Text 3"/>
           <p:cNvSpPr/>
           <p:nvPr/>
         </p:nvSpPr>
@@ -36003,92 +35709,14 @@
       </p:grpSpPr>
       <p:sp>
         <p:nvSpPr>
-          <p:cNvPr id="2" name="Text 0"/>
-          <p:cNvSpPr/>
-          <p:nvPr/>
-        </p:nvSpPr>
-        <p:spPr>
-          <a:xfrm>
-            <a:off x="502920" y="6437376"/>
-            <a:ext cx="10268712" cy="310896"/>
-          </a:xfrm>
-          <a:prstGeom prst="rect">
-            <a:avLst/>
-          </a:prstGeom>
-          <a:noFill/>
-          <a:ln/>
-        </p:spPr>
-        <p:txBody>
-          <a:bodyPr wrap="square" rtlCol="0" anchor="ctr"/>
-          <a:lstStyle/>
-          <a:p>
-            <a:pPr indent="0" marL="0">
-              <a:buNone/>
-            </a:pPr>
-            <a:r>
-              <a:rPr lang="en-US" sz="1200" dirty="0">
-                <a:solidFill>
-                  <a:srgbClr val="6B7280"/>
-                </a:solidFill>
-                <a:latin typeface="Aptos" pitchFamily="34" charset="0"/>
-                <a:ea typeface="Aptos" pitchFamily="34" charset="-122"/>
-                <a:cs typeface="Aptos" pitchFamily="34" charset="-120"/>
-              </a:rPr>
-              <a:t>US 252034 · Monitor and evaluate team members against performance standards · NQF 5 · 8 credits</a:t>
-            </a:r>
-            <a:endParaRPr lang="en-US" sz="1200" dirty="0"/>
-          </a:p>
-        </p:txBody>
-      </p:sp>
-      <p:sp>
-        <p:nvSpPr>
-          <p:cNvPr id="3" name="Text 1"/>
-          <p:cNvSpPr/>
-          <p:nvPr/>
-        </p:nvSpPr>
-        <p:spPr>
-          <a:xfrm>
-            <a:off x="11045952" y="6437376"/>
-            <a:ext cx="640080" cy="310896"/>
-          </a:xfrm>
-          <a:prstGeom prst="rect">
-            <a:avLst/>
-          </a:prstGeom>
-          <a:noFill/>
-          <a:ln/>
-        </p:spPr>
-        <p:txBody>
-          <a:bodyPr wrap="square" rtlCol="0" anchor="ctr"/>
-          <a:lstStyle/>
-          <a:p>
-            <a:pPr algn="r" indent="0" marL="0">
-              <a:buNone/>
-            </a:pPr>
-            <a:r>
-              <a:rPr lang="en-US" sz="1200" dirty="0">
-                <a:solidFill>
-                  <a:srgbClr val="6B7280"/>
-                </a:solidFill>
-                <a:latin typeface="Aptos" pitchFamily="34" charset="0"/>
-                <a:ea typeface="Aptos" pitchFamily="34" charset="-122"/>
-                <a:cs typeface="Aptos" pitchFamily="34" charset="-120"/>
-              </a:rPr>
-              <a:t>53</a:t>
-            </a:r>
-            <a:endParaRPr lang="en-US" sz="1200" dirty="0"/>
-          </a:p>
-        </p:txBody>
-      </p:sp>
-      <p:sp>
-        <p:nvSpPr>
-          <p:cNvPr id="4" name="Shape 2"/>
+          <p:cNvPr id="2" name="Shape 0"/>
           <p:cNvSpPr/>
           <p:nvPr/>
         </p:nvSpPr>
         <p:spPr>
           <a:xfrm>
             <a:off x="0" y="0"/>
-            <a:ext cx="12188952" cy="82296"/>
+            <a:ext cx="12188952" cy="109728"/>
           </a:xfrm>
           <a:prstGeom prst="rect">
             <a:avLst/>
@@ -36099,29 +35727,9 @@
           <a:ln/>
         </p:spPr>
       </p:sp>
-      <p:sp>
-        <p:nvSpPr>
-          <p:cNvPr id="5" name="Shape 3"/>
-          <p:cNvSpPr/>
-          <p:nvPr/>
-        </p:nvSpPr>
-        <p:spPr>
-          <a:xfrm>
-            <a:off x="0" y="0"/>
-            <a:ext cx="12188952" cy="109728"/>
-          </a:xfrm>
-          <a:prstGeom prst="rect">
-            <a:avLst/>
-          </a:prstGeom>
-          <a:solidFill>
-            <a:srgbClr val="0F6CBD"/>
-          </a:solidFill>
-          <a:ln/>
-        </p:spPr>
-      </p:sp>
       <p:pic>
         <p:nvPicPr>
-          <p:cNvPr id="6" name="Image 0" descr="preencoded.png">    </p:cNvPr>
+          <p:cNvPr id="3" name="Image 0" descr="preencoded.png">    </p:cNvPr>
           <p:cNvPicPr>
             <a:picLocks noChangeAspect="1"/>
           </p:cNvPicPr>
@@ -36151,7 +35759,7 @@
       </p:pic>
       <p:sp>
         <p:nvSpPr>
-          <p:cNvPr id="7" name="Text 4"/>
+          <p:cNvPr id="4" name="Text 1"/>
           <p:cNvSpPr/>
           <p:nvPr/>
         </p:nvSpPr>
@@ -36190,7 +35798,7 @@
       </p:sp>
       <p:sp>
         <p:nvSpPr>
-          <p:cNvPr id="8" name="Text 5"/>
+          <p:cNvPr id="5" name="Text 2"/>
           <p:cNvSpPr/>
           <p:nvPr/>
         </p:nvSpPr>
@@ -36232,7 +35840,7 @@
       </p:sp>
       <p:sp>
         <p:nvSpPr>
-          <p:cNvPr id="9" name="Text 6"/>
+          <p:cNvPr id="6" name="Text 3"/>
           <p:cNvSpPr/>
           <p:nvPr/>
         </p:nvSpPr>

</xml_diff>